<commit_message>
More files add for presentation
</commit_message>
<xml_diff>
--- a/presentation.pptx
+++ b/presentation.pptx
@@ -10,10 +10,11 @@
     <p:sldId id="265" r:id="rId7"/>
     <p:sldId id="270" r:id="rId8"/>
     <p:sldId id="271" r:id="rId9"/>
-    <p:sldId id="272" r:id="rId10"/>
-    <p:sldId id="273" r:id="rId11"/>
-    <p:sldId id="274" r:id="rId12"/>
-    <p:sldId id="264" r:id="rId13"/>
+    <p:sldId id="275" r:id="rId10"/>
+    <p:sldId id="272" r:id="rId11"/>
+    <p:sldId id="273" r:id="rId12"/>
+    <p:sldId id="274" r:id="rId13"/>
+    <p:sldId id="264" r:id="rId14"/>
   </p:sldIdLst>
   <p:sldSz cx="12192000" cy="6858000"/>
   <p:notesSz cx="6858000" cy="9144000"/>
@@ -132,8 +133,8 @@
 <pc:chgInfo xmlns:a="http://schemas.openxmlformats.org/drawingml/2006/main" xmlns:r="http://schemas.openxmlformats.org/officeDocument/2006/relationships" xmlns:ac="http://schemas.microsoft.com/office/drawing/2013/main/command" xmlns:pc="http://schemas.microsoft.com/office/powerpoint/2013/main/command">
   <pc:docChgLst>
     <pc:chgData name="O'Donovan Murphy II" userId="9aba7750f0050ce0" providerId="LiveId" clId="{58B0EFE8-61E5-4433-BE63-CD640EBE0A09}"/>
-    <pc:docChg chg="undo custSel modSld sldOrd">
-      <pc:chgData name="O'Donovan Murphy II" userId="9aba7750f0050ce0" providerId="LiveId" clId="{58B0EFE8-61E5-4433-BE63-CD640EBE0A09}" dt="2026-04-30T23:36:39.631" v="931" actId="20577"/>
+    <pc:docChg chg="undo custSel addSld modSld sldOrd">
+      <pc:chgData name="O'Donovan Murphy II" userId="9aba7750f0050ce0" providerId="LiveId" clId="{58B0EFE8-61E5-4433-BE63-CD640EBE0A09}" dt="2026-05-02T01:31:07.250" v="973" actId="1076"/>
       <pc:docMkLst>
         <pc:docMk/>
       </pc:docMkLst>
@@ -212,51 +213,74 @@
             <ac:spMk id="3" creationId="{C90D0AC2-81B7-4B98-A6FF-97CD47666451}"/>
           </ac:spMkLst>
         </pc:spChg>
-        <pc:picChg chg="del">
-          <ac:chgData name="O'Donovan Murphy II" userId="9aba7750f0050ce0" providerId="LiveId" clId="{58B0EFE8-61E5-4433-BE63-CD640EBE0A09}" dt="2026-04-30T23:31:06.570" v="621" actId="478"/>
-          <ac:picMkLst>
-            <pc:docMk/>
-            <pc:sldMk cId="478154369" sldId="270"/>
-            <ac:picMk id="1026" creationId="{1A834593-88B1-41D2-82A9-05D6DCE6EF68}"/>
-          </ac:picMkLst>
-        </pc:picChg>
       </pc:sldChg>
-      <pc:sldChg chg="delSp modSp mod">
-        <pc:chgData name="O'Donovan Murphy II" userId="9aba7750f0050ce0" providerId="LiveId" clId="{58B0EFE8-61E5-4433-BE63-CD640EBE0A09}" dt="2026-04-30T23:36:39.631" v="931" actId="20577"/>
+      <pc:sldChg chg="addSp delSp modSp mod">
+        <pc:chgData name="O'Donovan Murphy II" userId="9aba7750f0050ce0" providerId="LiveId" clId="{58B0EFE8-61E5-4433-BE63-CD640EBE0A09}" dt="2026-05-02T00:58:35.928" v="947" actId="1076"/>
         <pc:sldMkLst>
           <pc:docMk/>
           <pc:sldMk cId="3111760962" sldId="271"/>
         </pc:sldMkLst>
         <pc:spChg chg="mod">
-          <ac:chgData name="O'Donovan Murphy II" userId="9aba7750f0050ce0" providerId="LiveId" clId="{58B0EFE8-61E5-4433-BE63-CD640EBE0A09}" dt="2026-04-30T23:35:02.004" v="927" actId="20577"/>
+          <ac:chgData name="O'Donovan Murphy II" userId="9aba7750f0050ce0" providerId="LiveId" clId="{58B0EFE8-61E5-4433-BE63-CD640EBE0A09}" dt="2026-05-02T00:57:38.617" v="940" actId="20577"/>
           <ac:spMkLst>
             <pc:docMk/>
             <pc:sldMk cId="3111760962" sldId="271"/>
             <ac:spMk id="2" creationId="{40F62B8A-EBE9-4AC6-AA22-80E16FBF18D0}"/>
           </ac:spMkLst>
         </pc:spChg>
-        <pc:spChg chg="mod">
-          <ac:chgData name="O'Donovan Murphy II" userId="9aba7750f0050ce0" providerId="LiveId" clId="{58B0EFE8-61E5-4433-BE63-CD640EBE0A09}" dt="2026-04-30T23:36:39.631" v="931" actId="20577"/>
+        <pc:spChg chg="del mod">
+          <ac:chgData name="O'Donovan Murphy II" userId="9aba7750f0050ce0" providerId="LiveId" clId="{58B0EFE8-61E5-4433-BE63-CD640EBE0A09}" dt="2026-05-02T00:58:15.775" v="941" actId="931"/>
           <ac:spMkLst>
             <pc:docMk/>
             <pc:sldMk cId="3111760962" sldId="271"/>
             <ac:spMk id="3" creationId="{3B816813-9340-4DB1-B639-6B0443DD046D}"/>
           </ac:spMkLst>
         </pc:spChg>
-        <pc:spChg chg="del mod">
-          <ac:chgData name="O'Donovan Murphy II" userId="9aba7750f0050ce0" providerId="LiveId" clId="{58B0EFE8-61E5-4433-BE63-CD640EBE0A09}" dt="2026-04-30T23:36:36.227" v="930" actId="478"/>
+        <pc:picChg chg="add mod ord">
+          <ac:chgData name="O'Donovan Murphy II" userId="9aba7750f0050ce0" providerId="LiveId" clId="{58B0EFE8-61E5-4433-BE63-CD640EBE0A09}" dt="2026-05-02T00:58:35.928" v="947" actId="1076"/>
+          <ac:picMkLst>
+            <pc:docMk/>
+            <pc:sldMk cId="3111760962" sldId="271"/>
+            <ac:picMk id="5" creationId="{1851F2A0-8EC7-055D-BDBE-8602C62102E3}"/>
+          </ac:picMkLst>
+        </pc:picChg>
+      </pc:sldChg>
+      <pc:sldChg chg="addSp delSp modSp add mod">
+        <pc:chgData name="O'Donovan Murphy II" userId="9aba7750f0050ce0" providerId="LiveId" clId="{58B0EFE8-61E5-4433-BE63-CD640EBE0A09}" dt="2026-05-02T01:31:07.250" v="973" actId="1076"/>
+        <pc:sldMkLst>
+          <pc:docMk/>
+          <pc:sldMk cId="2699978075" sldId="275"/>
+        </pc:sldMkLst>
+        <pc:spChg chg="mod">
+          <ac:chgData name="O'Donovan Murphy II" userId="9aba7750f0050ce0" providerId="LiveId" clId="{58B0EFE8-61E5-4433-BE63-CD640EBE0A09}" dt="2026-05-02T01:08:29.375" v="963" actId="20577"/>
           <ac:spMkLst>
             <pc:docMk/>
-            <pc:sldMk cId="3111760962" sldId="271"/>
-            <ac:spMk id="4" creationId="{9CC82BA5-42C4-4C2F-9DCD-73AB0B25A8F7}"/>
+            <pc:sldMk cId="2699978075" sldId="275"/>
+            <ac:spMk id="2" creationId="{82862712-0201-22A8-4998-F65F0F91BB2A}"/>
+          </ac:spMkLst>
+        </pc:spChg>
+        <pc:spChg chg="add del mod">
+          <ac:chgData name="O'Donovan Murphy II" userId="9aba7750f0050ce0" providerId="LiveId" clId="{58B0EFE8-61E5-4433-BE63-CD640EBE0A09}" dt="2026-05-02T01:30:37.807" v="964" actId="931"/>
+          <ac:spMkLst>
+            <pc:docMk/>
+            <pc:sldMk cId="2699978075" sldId="275"/>
+            <ac:spMk id="4" creationId="{FDBDF90F-2703-179C-724F-5FF102F032A2}"/>
           </ac:spMkLst>
         </pc:spChg>
         <pc:picChg chg="del">
-          <ac:chgData name="O'Donovan Murphy II" userId="9aba7750f0050ce0" providerId="LiveId" clId="{58B0EFE8-61E5-4433-BE63-CD640EBE0A09}" dt="2026-04-30T23:34:31.933" v="835" actId="478"/>
+          <ac:chgData name="O'Donovan Murphy II" userId="9aba7750f0050ce0" providerId="LiveId" clId="{58B0EFE8-61E5-4433-BE63-CD640EBE0A09}" dt="2026-05-02T01:08:24.453" v="949" actId="478"/>
           <ac:picMkLst>
             <pc:docMk/>
-            <pc:sldMk cId="3111760962" sldId="271"/>
-            <ac:picMk id="2050" creationId="{F456C839-4F39-4BDB-90AE-BAA842A4ED43}"/>
+            <pc:sldMk cId="2699978075" sldId="275"/>
+            <ac:picMk id="5" creationId="{DD9013E2-F249-01DE-67FB-7D4FED22B8A2}"/>
+          </ac:picMkLst>
+        </pc:picChg>
+        <pc:picChg chg="add mod ord">
+          <ac:chgData name="O'Donovan Murphy II" userId="9aba7750f0050ce0" providerId="LiveId" clId="{58B0EFE8-61E5-4433-BE63-CD640EBE0A09}" dt="2026-05-02T01:31:07.250" v="973" actId="1076"/>
+          <ac:picMkLst>
+            <pc:docMk/>
+            <pc:sldMk cId="2699978075" sldId="275"/>
+            <ac:picMk id="7" creationId="{A9FBA578-2AFD-8E1D-1ACD-570517BA7DF0}"/>
           </ac:picMkLst>
         </pc:picChg>
       </pc:sldChg>
@@ -4243,7 +4267,7 @@
           <a:p>
             <a:fld id="{966E0282-BF4E-46E2-B869-4BA1A62D6C6E}" type="datetimeFigureOut">
               <a:rPr lang="en-US" smtClean="0"/>
-              <a:t>4/30/2026</a:t>
+              <a:t>5/1/2026</a:t>
             </a:fld>
             <a:endParaRPr lang="en-US"/>
           </a:p>
@@ -4441,7 +4465,7 @@
           <a:p>
             <a:fld id="{966E0282-BF4E-46E2-B869-4BA1A62D6C6E}" type="datetimeFigureOut">
               <a:rPr lang="en-US" smtClean="0"/>
-              <a:t>4/30/2026</a:t>
+              <a:t>5/1/2026</a:t>
             </a:fld>
             <a:endParaRPr lang="en-US"/>
           </a:p>
@@ -4649,7 +4673,7 @@
           <a:p>
             <a:fld id="{966E0282-BF4E-46E2-B869-4BA1A62D6C6E}" type="datetimeFigureOut">
               <a:rPr lang="en-US" smtClean="0"/>
-              <a:t>4/30/2026</a:t>
+              <a:t>5/1/2026</a:t>
             </a:fld>
             <a:endParaRPr lang="en-US"/>
           </a:p>
@@ -4847,7 +4871,7 @@
           <a:p>
             <a:fld id="{966E0282-BF4E-46E2-B869-4BA1A62D6C6E}" type="datetimeFigureOut">
               <a:rPr lang="en-US" smtClean="0"/>
-              <a:t>4/30/2026</a:t>
+              <a:t>5/1/2026</a:t>
             </a:fld>
             <a:endParaRPr lang="en-US"/>
           </a:p>
@@ -5122,7 +5146,7 @@
           <a:p>
             <a:fld id="{966E0282-BF4E-46E2-B869-4BA1A62D6C6E}" type="datetimeFigureOut">
               <a:rPr lang="en-US" smtClean="0"/>
-              <a:t>4/30/2026</a:t>
+              <a:t>5/1/2026</a:t>
             </a:fld>
             <a:endParaRPr lang="en-US"/>
           </a:p>
@@ -5387,7 +5411,7 @@
           <a:p>
             <a:fld id="{966E0282-BF4E-46E2-B869-4BA1A62D6C6E}" type="datetimeFigureOut">
               <a:rPr lang="en-US" smtClean="0"/>
-              <a:t>4/30/2026</a:t>
+              <a:t>5/1/2026</a:t>
             </a:fld>
             <a:endParaRPr lang="en-US"/>
           </a:p>
@@ -5799,7 +5823,7 @@
           <a:p>
             <a:fld id="{966E0282-BF4E-46E2-B869-4BA1A62D6C6E}" type="datetimeFigureOut">
               <a:rPr lang="en-US" smtClean="0"/>
-              <a:t>4/30/2026</a:t>
+              <a:t>5/1/2026</a:t>
             </a:fld>
             <a:endParaRPr lang="en-US"/>
           </a:p>
@@ -5940,7 +5964,7 @@
           <a:p>
             <a:fld id="{966E0282-BF4E-46E2-B869-4BA1A62D6C6E}" type="datetimeFigureOut">
               <a:rPr lang="en-US" smtClean="0"/>
-              <a:t>4/30/2026</a:t>
+              <a:t>5/1/2026</a:t>
             </a:fld>
             <a:endParaRPr lang="en-US"/>
           </a:p>
@@ -6053,7 +6077,7 @@
           <a:p>
             <a:fld id="{966E0282-BF4E-46E2-B869-4BA1A62D6C6E}" type="datetimeFigureOut">
               <a:rPr lang="en-US" smtClean="0"/>
-              <a:t>4/30/2026</a:t>
+              <a:t>5/1/2026</a:t>
             </a:fld>
             <a:endParaRPr lang="en-US"/>
           </a:p>
@@ -6364,7 +6388,7 @@
           <a:p>
             <a:fld id="{966E0282-BF4E-46E2-B869-4BA1A62D6C6E}" type="datetimeFigureOut">
               <a:rPr lang="en-US" smtClean="0"/>
-              <a:t>4/30/2026</a:t>
+              <a:t>5/1/2026</a:t>
             </a:fld>
             <a:endParaRPr lang="en-US"/>
           </a:p>
@@ -6652,7 +6676,7 @@
           <a:p>
             <a:fld id="{966E0282-BF4E-46E2-B869-4BA1A62D6C6E}" type="datetimeFigureOut">
               <a:rPr lang="en-US" smtClean="0"/>
-              <a:t>4/30/2026</a:t>
+              <a:t>5/1/2026</a:t>
             </a:fld>
             <a:endParaRPr lang="en-US"/>
           </a:p>
@@ -6893,7 +6917,7 @@
           <a:p>
             <a:fld id="{966E0282-BF4E-46E2-B869-4BA1A62D6C6E}" type="datetimeFigureOut">
               <a:rPr lang="en-US" smtClean="0"/>
-              <a:t>4/30/2026</a:t>
+              <a:t>5/1/2026</a:t>
             </a:fld>
             <a:endParaRPr lang="en-US"/>
           </a:p>
@@ -7398,6 +7422,203 @@
 </p:sld>
 </file>
 
+<file path=ppt/slides/slide10.xml><?xml version="1.0" encoding="utf-8"?>
+<p:sld xmlns:a="http://schemas.openxmlformats.org/drawingml/2006/main" xmlns:r="http://schemas.openxmlformats.org/officeDocument/2006/relationships" xmlns:p="http://schemas.openxmlformats.org/presentationml/2006/main">
+  <p:cSld>
+    <p:bg>
+      <p:bgPr>
+        <a:solidFill>
+          <a:schemeClr val="bg1"/>
+        </a:solidFill>
+        <a:effectLst/>
+      </p:bgPr>
+    </p:bg>
+    <p:spTree>
+      <p:nvGrpSpPr>
+        <p:cNvPr id="1" name=""/>
+        <p:cNvGrpSpPr/>
+        <p:nvPr/>
+      </p:nvGrpSpPr>
+      <p:grpSpPr>
+        <a:xfrm>
+          <a:off x="0" y="0"/>
+          <a:ext cx="0" cy="0"/>
+          <a:chOff x="0" y="0"/>
+          <a:chExt cx="0" cy="0"/>
+        </a:xfrm>
+      </p:grpSpPr>
+      <p:sp>
+        <p:nvSpPr>
+          <p:cNvPr id="9" name="Rectangle 8">
+            <a:extLst>
+              <a:ext uri="{FF2B5EF4-FFF2-40B4-BE49-F238E27FC236}">
+                <a16:creationId xmlns:a16="http://schemas.microsoft.com/office/drawing/2014/main" id="{3A5B4632-C963-4296-86F0-79AA9EA5AE98}"/>
+              </a:ext>
+              <a:ext uri="{C183D7F6-B498-43B3-948B-1728B52AA6E4}">
+                <adec:decorative xmlns:adec="http://schemas.microsoft.com/office/drawing/2017/decorative" val="1"/>
+              </a:ext>
+            </a:extLst>
+          </p:cNvPr>
+          <p:cNvSpPr>
+            <a:spLocks noGrp="1" noRot="1" noChangeAspect="1" noMove="1" noResize="1" noEditPoints="1" noAdjustHandles="1" noChangeArrowheads="1" noChangeShapeType="1" noTextEdit="1"/>
+          </p:cNvSpPr>
+          <p:nvPr>
+            <p:extLst>
+              <p:ext uri="{386F3935-93C4-4BCD-93E2-E3B085C9AB24}">
+                <p16:designElem xmlns:p16="http://schemas.microsoft.com/office/powerpoint/2015/main" val="1"/>
+              </p:ext>
+            </p:extLst>
+          </p:nvPr>
+        </p:nvSpPr>
+        <p:spPr bwMode="ltGray">
+          <a:xfrm>
+            <a:off x="338328" y="303591"/>
+            <a:ext cx="4335327" cy="5896743"/>
+          </a:xfrm>
+          <a:prstGeom prst="rect">
+            <a:avLst/>
+          </a:prstGeom>
+          <a:solidFill>
+            <a:schemeClr val="tx1">
+              <a:lumMod val="75000"/>
+              <a:lumOff val="25000"/>
+            </a:schemeClr>
+          </a:solidFill>
+          <a:ln w="127000" cap="sq" cmpd="thinThick">
+            <a:solidFill>
+              <a:schemeClr val="tx1">
+                <a:lumMod val="75000"/>
+                <a:lumOff val="25000"/>
+              </a:schemeClr>
+            </a:solidFill>
+          </a:ln>
+        </p:spPr>
+        <p:style>
+          <a:lnRef idx="2">
+            <a:schemeClr val="accent1">
+              <a:shade val="50000"/>
+            </a:schemeClr>
+          </a:lnRef>
+          <a:fillRef idx="1">
+            <a:schemeClr val="accent1"/>
+          </a:fillRef>
+          <a:effectRef idx="0">
+            <a:schemeClr val="accent1"/>
+          </a:effectRef>
+          <a:fontRef idx="minor">
+            <a:schemeClr val="lt1"/>
+          </a:fontRef>
+        </p:style>
+        <p:txBody>
+          <a:bodyPr rtlCol="0" anchor="ctr"/>
+          <a:lstStyle/>
+          <a:p>
+            <a:pPr algn="ctr"/>
+            <a:endParaRPr lang="en-US"/>
+          </a:p>
+        </p:txBody>
+      </p:sp>
+      <p:sp>
+        <p:nvSpPr>
+          <p:cNvPr id="2" name="Title 1">
+            <a:extLst>
+              <a:ext uri="{FF2B5EF4-FFF2-40B4-BE49-F238E27FC236}">
+                <a16:creationId xmlns:a16="http://schemas.microsoft.com/office/drawing/2014/main" id="{6384583C-B7FD-4EF7-85EB-F116BBCB7DDC}"/>
+              </a:ext>
+            </a:extLst>
+          </p:cNvPr>
+          <p:cNvSpPr>
+            <a:spLocks noGrp="1"/>
+          </p:cNvSpPr>
+          <p:nvPr>
+            <p:ph type="title"/>
+          </p:nvPr>
+        </p:nvSpPr>
+        <p:spPr>
+          <a:xfrm>
+            <a:off x="594360" y="637125"/>
+            <a:ext cx="3802276" cy="5256371"/>
+          </a:xfrm>
+        </p:spPr>
+        <p:txBody>
+          <a:bodyPr>
+            <a:normAutofit/>
+          </a:bodyPr>
+          <a:lstStyle/>
+          <a:p>
+            <a:pPr algn="ctr"/>
+            <a:r>
+              <a:rPr lang="en-US" sz="8000" dirty="0">
+                <a:solidFill>
+                  <a:schemeClr val="bg1"/>
+                </a:solidFill>
+                <a:latin typeface="Algerian" panose="04020705040A02060702" pitchFamily="82" charset="0"/>
+              </a:rPr>
+              <a:t>Note </a:t>
+            </a:r>
+            <a:r>
+              <a:rPr lang="en-US" sz="8000" dirty="0">
+                <a:solidFill>
+                  <a:schemeClr val="bg1"/>
+                </a:solidFill>
+                <a:latin typeface="Algerian" panose="04020705040A02060702" pitchFamily="82" charset="0"/>
+                <a:sym typeface="Wingdings" panose="05000000000000000000" pitchFamily="2" charset="2"/>
+              </a:rPr>
+              <a:t></a:t>
+            </a:r>
+            <a:endParaRPr lang="en-US" sz="4800" dirty="0">
+              <a:solidFill>
+                <a:schemeClr val="bg1"/>
+              </a:solidFill>
+              <a:latin typeface="Algerian" panose="04020705040A02060702" pitchFamily="82" charset="0"/>
+            </a:endParaRPr>
+          </a:p>
+        </p:txBody>
+      </p:sp>
+      <p:graphicFrame>
+        <p:nvGraphicFramePr>
+          <p:cNvPr id="5" name="Content Placeholder 2">
+            <a:extLst>
+              <a:ext uri="{FF2B5EF4-FFF2-40B4-BE49-F238E27FC236}">
+                <a16:creationId xmlns:a16="http://schemas.microsoft.com/office/drawing/2014/main" id="{D0EEF94E-37CA-A384-AB85-4720D6A94F86}"/>
+              </a:ext>
+            </a:extLst>
+          </p:cNvPr>
+          <p:cNvGraphicFramePr>
+            <a:graphicFrameLocks noGrp="1"/>
+          </p:cNvGraphicFramePr>
+          <p:nvPr>
+            <p:ph idx="1"/>
+            <p:extLst>
+              <p:ext uri="{D42A27DB-BD31-4B8C-83A1-F6EECF244321}">
+                <p14:modId xmlns:p14="http://schemas.microsoft.com/office/powerpoint/2010/main" val="1711259026"/>
+              </p:ext>
+            </p:extLst>
+          </p:nvPr>
+        </p:nvGraphicFramePr>
+        <p:xfrm>
+          <a:off x="5166985" y="303591"/>
+          <a:ext cx="6588691" cy="5896743"/>
+        </p:xfrm>
+        <a:graphic>
+          <a:graphicData uri="http://schemas.openxmlformats.org/drawingml/2006/diagram">
+            <dgm:relIds xmlns:dgm="http://schemas.openxmlformats.org/drawingml/2006/diagram" xmlns:r="http://schemas.openxmlformats.org/officeDocument/2006/relationships" r:dm="rId2" r:lo="rId3" r:qs="rId4" r:cs="rId5"/>
+          </a:graphicData>
+        </a:graphic>
+      </p:graphicFrame>
+    </p:spTree>
+    <p:extLst>
+      <p:ext uri="{BB962C8B-B14F-4D97-AF65-F5344CB8AC3E}">
+        <p14:creationId xmlns:p14="http://schemas.microsoft.com/office/powerpoint/2010/main" val="314255409"/>
+      </p:ext>
+    </p:extLst>
+  </p:cSld>
+  <p:clrMapOvr>
+    <a:masterClrMapping/>
+  </p:clrMapOvr>
+</p:sld>
+</file>
+
 <file path=ppt/slides/slide2.xml><?xml version="1.0" encoding="utf-8"?>
 <p:sld xmlns:a="http://schemas.openxmlformats.org/drawingml/2006/main" xmlns:r="http://schemas.openxmlformats.org/officeDocument/2006/relationships" xmlns:p="http://schemas.openxmlformats.org/presentationml/2006/main">
   <p:cSld>
@@ -7755,37 +7976,49 @@
           <a:p>
             <a:r>
               <a:rPr lang="en-US" dirty="0"/>
-              <a:t>Software Flowchart</a:t>
+              <a:t>Software Flowchart - Client</a:t>
             </a:r>
           </a:p>
         </p:txBody>
       </p:sp>
-      <p:sp>
-        <p:nvSpPr>
-          <p:cNvPr id="3" name="Content Placeholder 2">
+      <p:pic>
+        <p:nvPicPr>
+          <p:cNvPr id="5" name="Content Placeholder 4">
             <a:extLst>
               <a:ext uri="{FF2B5EF4-FFF2-40B4-BE49-F238E27FC236}">
-                <a16:creationId xmlns:a16="http://schemas.microsoft.com/office/drawing/2014/main" id="{3B816813-9340-4DB1-B639-6B0443DD046D}"/>
+                <a16:creationId xmlns:a16="http://schemas.microsoft.com/office/drawing/2014/main" id="{1851F2A0-8EC7-055D-BDBE-8602C62102E3}"/>
               </a:ext>
             </a:extLst>
           </p:cNvPr>
-          <p:cNvSpPr>
-            <a:spLocks noGrp="1"/>
-          </p:cNvSpPr>
+          <p:cNvPicPr>
+            <a:picLocks noGrp="1" noChangeAspect="1"/>
+          </p:cNvPicPr>
           <p:nvPr>
             <p:ph idx="1"/>
           </p:nvPr>
-        </p:nvSpPr>
-        <p:spPr/>
-        <p:txBody>
-          <a:bodyPr/>
-          <a:lstStyle/>
-          <a:p>
-            <a:pPr lvl="1"/>
-            <a:endParaRPr lang="en-US" dirty="0"/>
-          </a:p>
-        </p:txBody>
-      </p:sp>
+        </p:nvPicPr>
+        <p:blipFill>
+          <a:blip>
+            <a:extLst>
+              <a:ext uri="{96DAC541-7B7A-43D3-8B79-37D633B846F1}">
+                <asvg:svgBlip xmlns:asvg="http://schemas.microsoft.com/office/drawing/2016/SVG/main" r:embed="rId2"/>
+              </a:ext>
+            </a:extLst>
+          </a:blip>
+          <a:stretch>
+            <a:fillRect/>
+          </a:stretch>
+        </p:blipFill>
+        <p:spPr>
+          <a:xfrm>
+            <a:off x="1828800" y="1452944"/>
+            <a:ext cx="7315200" cy="4735206"/>
+          </a:xfrm>
+          <a:prstGeom prst="rect">
+            <a:avLst/>
+          </a:prstGeom>
+        </p:spPr>
+      </p:pic>
     </p:spTree>
     <p:extLst>
       <p:ext uri="{BB962C8B-B14F-4D97-AF65-F5344CB8AC3E}">
@@ -7800,6 +8033,108 @@
 </file>
 
 <file path=ppt/slides/slide6.xml><?xml version="1.0" encoding="utf-8"?>
+<p:sld xmlns:a="http://schemas.openxmlformats.org/drawingml/2006/main" xmlns:r="http://schemas.openxmlformats.org/officeDocument/2006/relationships" xmlns:p="http://schemas.openxmlformats.org/presentationml/2006/main">
+  <p:cSld>
+    <p:spTree>
+      <p:nvGrpSpPr>
+        <p:cNvPr id="1" name="">
+          <a:extLst>
+            <a:ext uri="{FF2B5EF4-FFF2-40B4-BE49-F238E27FC236}">
+              <a16:creationId xmlns:a16="http://schemas.microsoft.com/office/drawing/2014/main" id="{1B3CE4F1-2AAC-3626-CB31-259C65A3408B}"/>
+            </a:ext>
+          </a:extLst>
+        </p:cNvPr>
+        <p:cNvGrpSpPr/>
+        <p:nvPr/>
+      </p:nvGrpSpPr>
+      <p:grpSpPr>
+        <a:xfrm>
+          <a:off x="0" y="0"/>
+          <a:ext cx="0" cy="0"/>
+          <a:chOff x="0" y="0"/>
+          <a:chExt cx="0" cy="0"/>
+        </a:xfrm>
+      </p:grpSpPr>
+      <p:sp>
+        <p:nvSpPr>
+          <p:cNvPr id="2" name="Title 1">
+            <a:extLst>
+              <a:ext uri="{FF2B5EF4-FFF2-40B4-BE49-F238E27FC236}">
+                <a16:creationId xmlns:a16="http://schemas.microsoft.com/office/drawing/2014/main" id="{82862712-0201-22A8-4998-F65F0F91BB2A}"/>
+              </a:ext>
+            </a:extLst>
+          </p:cNvPr>
+          <p:cNvSpPr>
+            <a:spLocks noGrp="1"/>
+          </p:cNvSpPr>
+          <p:nvPr>
+            <p:ph type="title"/>
+          </p:nvPr>
+        </p:nvSpPr>
+        <p:spPr/>
+        <p:txBody>
+          <a:bodyPr/>
+          <a:lstStyle/>
+          <a:p>
+            <a:r>
+              <a:rPr lang="en-US" dirty="0"/>
+              <a:t>Software Flowchart - Server</a:t>
+            </a:r>
+          </a:p>
+        </p:txBody>
+      </p:sp>
+      <p:pic>
+        <p:nvPicPr>
+          <p:cNvPr id="7" name="Content Placeholder 6">
+            <a:extLst>
+              <a:ext uri="{FF2B5EF4-FFF2-40B4-BE49-F238E27FC236}">
+                <a16:creationId xmlns:a16="http://schemas.microsoft.com/office/drawing/2014/main" id="{A9FBA578-2AFD-8E1D-1ACD-570517BA7DF0}"/>
+              </a:ext>
+            </a:extLst>
+          </p:cNvPr>
+          <p:cNvPicPr>
+            <a:picLocks noGrp="1" noChangeAspect="1"/>
+          </p:cNvPicPr>
+          <p:nvPr>
+            <p:ph idx="1"/>
+          </p:nvPr>
+        </p:nvPicPr>
+        <p:blipFill>
+          <a:blip>
+            <a:extLst>
+              <a:ext uri="{96DAC541-7B7A-43D3-8B79-37D633B846F1}">
+                <asvg:svgBlip xmlns:asvg="http://schemas.microsoft.com/office/drawing/2016/SVG/main" r:embed="rId2"/>
+              </a:ext>
+            </a:extLst>
+          </a:blip>
+          <a:stretch>
+            <a:fillRect/>
+          </a:stretch>
+        </p:blipFill>
+        <p:spPr>
+          <a:xfrm>
+            <a:off x="3553968" y="1690688"/>
+            <a:ext cx="5084063" cy="4760871"/>
+          </a:xfrm>
+          <a:prstGeom prst="rect">
+            <a:avLst/>
+          </a:prstGeom>
+        </p:spPr>
+      </p:pic>
+    </p:spTree>
+    <p:extLst>
+      <p:ext uri="{BB962C8B-B14F-4D97-AF65-F5344CB8AC3E}">
+        <p14:creationId xmlns:p14="http://schemas.microsoft.com/office/powerpoint/2010/main" val="2699978075"/>
+      </p:ext>
+    </p:extLst>
+  </p:cSld>
+  <p:clrMapOvr>
+    <a:masterClrMapping/>
+  </p:clrMapOvr>
+</p:sld>
+</file>
+
+<file path=ppt/slides/slide7.xml><?xml version="1.0" encoding="utf-8"?>
 <p:sld xmlns:a="http://schemas.openxmlformats.org/drawingml/2006/main" xmlns:r="http://schemas.openxmlformats.org/officeDocument/2006/relationships" xmlns:p="http://schemas.openxmlformats.org/presentationml/2006/main">
   <p:cSld>
     <p:spTree>
@@ -8014,7 +8349,7 @@
 </p:sld>
 </file>
 
-<file path=ppt/slides/slide7.xml><?xml version="1.0" encoding="utf-8"?>
+<file path=ppt/slides/slide8.xml><?xml version="1.0" encoding="utf-8"?>
 <p:sld xmlns:a="http://schemas.openxmlformats.org/drawingml/2006/main" xmlns:r="http://schemas.openxmlformats.org/officeDocument/2006/relationships" xmlns:p="http://schemas.openxmlformats.org/presentationml/2006/main">
   <p:cSld>
     <p:spTree>
@@ -8172,7 +8507,7 @@
 </p:sld>
 </file>
 
-<file path=ppt/slides/slide8.xml><?xml version="1.0" encoding="utf-8"?>
+<file path=ppt/slides/slide9.xml><?xml version="1.0" encoding="utf-8"?>
 <p:sld xmlns:a="http://schemas.openxmlformats.org/drawingml/2006/main" xmlns:r="http://schemas.openxmlformats.org/officeDocument/2006/relationships" xmlns:p="http://schemas.openxmlformats.org/presentationml/2006/main">
   <p:cSld>
     <p:spTree>
@@ -9042,203 +9377,6 @@
 </p:sld>
 </file>
 
-<file path=ppt/slides/slide9.xml><?xml version="1.0" encoding="utf-8"?>
-<p:sld xmlns:a="http://schemas.openxmlformats.org/drawingml/2006/main" xmlns:r="http://schemas.openxmlformats.org/officeDocument/2006/relationships" xmlns:p="http://schemas.openxmlformats.org/presentationml/2006/main">
-  <p:cSld>
-    <p:bg>
-      <p:bgPr>
-        <a:solidFill>
-          <a:schemeClr val="bg1"/>
-        </a:solidFill>
-        <a:effectLst/>
-      </p:bgPr>
-    </p:bg>
-    <p:spTree>
-      <p:nvGrpSpPr>
-        <p:cNvPr id="1" name=""/>
-        <p:cNvGrpSpPr/>
-        <p:nvPr/>
-      </p:nvGrpSpPr>
-      <p:grpSpPr>
-        <a:xfrm>
-          <a:off x="0" y="0"/>
-          <a:ext cx="0" cy="0"/>
-          <a:chOff x="0" y="0"/>
-          <a:chExt cx="0" cy="0"/>
-        </a:xfrm>
-      </p:grpSpPr>
-      <p:sp>
-        <p:nvSpPr>
-          <p:cNvPr id="9" name="Rectangle 8">
-            <a:extLst>
-              <a:ext uri="{FF2B5EF4-FFF2-40B4-BE49-F238E27FC236}">
-                <a16:creationId xmlns:a16="http://schemas.microsoft.com/office/drawing/2014/main" id="{3A5B4632-C963-4296-86F0-79AA9EA5AE98}"/>
-              </a:ext>
-              <a:ext uri="{C183D7F6-B498-43B3-948B-1728B52AA6E4}">
-                <adec:decorative xmlns:adec="http://schemas.microsoft.com/office/drawing/2017/decorative" val="1"/>
-              </a:ext>
-            </a:extLst>
-          </p:cNvPr>
-          <p:cNvSpPr>
-            <a:spLocks noGrp="1" noRot="1" noChangeAspect="1" noMove="1" noResize="1" noEditPoints="1" noAdjustHandles="1" noChangeArrowheads="1" noChangeShapeType="1" noTextEdit="1"/>
-          </p:cNvSpPr>
-          <p:nvPr>
-            <p:extLst>
-              <p:ext uri="{386F3935-93C4-4BCD-93E2-E3B085C9AB24}">
-                <p16:designElem xmlns:p16="http://schemas.microsoft.com/office/powerpoint/2015/main" val="1"/>
-              </p:ext>
-            </p:extLst>
-          </p:nvPr>
-        </p:nvSpPr>
-        <p:spPr bwMode="ltGray">
-          <a:xfrm>
-            <a:off x="338328" y="303591"/>
-            <a:ext cx="4335327" cy="5896743"/>
-          </a:xfrm>
-          <a:prstGeom prst="rect">
-            <a:avLst/>
-          </a:prstGeom>
-          <a:solidFill>
-            <a:schemeClr val="tx1">
-              <a:lumMod val="75000"/>
-              <a:lumOff val="25000"/>
-            </a:schemeClr>
-          </a:solidFill>
-          <a:ln w="127000" cap="sq" cmpd="thinThick">
-            <a:solidFill>
-              <a:schemeClr val="tx1">
-                <a:lumMod val="75000"/>
-                <a:lumOff val="25000"/>
-              </a:schemeClr>
-            </a:solidFill>
-          </a:ln>
-        </p:spPr>
-        <p:style>
-          <a:lnRef idx="2">
-            <a:schemeClr val="accent1">
-              <a:shade val="50000"/>
-            </a:schemeClr>
-          </a:lnRef>
-          <a:fillRef idx="1">
-            <a:schemeClr val="accent1"/>
-          </a:fillRef>
-          <a:effectRef idx="0">
-            <a:schemeClr val="accent1"/>
-          </a:effectRef>
-          <a:fontRef idx="minor">
-            <a:schemeClr val="lt1"/>
-          </a:fontRef>
-        </p:style>
-        <p:txBody>
-          <a:bodyPr rtlCol="0" anchor="ctr"/>
-          <a:lstStyle/>
-          <a:p>
-            <a:pPr algn="ctr"/>
-            <a:endParaRPr lang="en-US"/>
-          </a:p>
-        </p:txBody>
-      </p:sp>
-      <p:sp>
-        <p:nvSpPr>
-          <p:cNvPr id="2" name="Title 1">
-            <a:extLst>
-              <a:ext uri="{FF2B5EF4-FFF2-40B4-BE49-F238E27FC236}">
-                <a16:creationId xmlns:a16="http://schemas.microsoft.com/office/drawing/2014/main" id="{6384583C-B7FD-4EF7-85EB-F116BBCB7DDC}"/>
-              </a:ext>
-            </a:extLst>
-          </p:cNvPr>
-          <p:cNvSpPr>
-            <a:spLocks noGrp="1"/>
-          </p:cNvSpPr>
-          <p:nvPr>
-            <p:ph type="title"/>
-          </p:nvPr>
-        </p:nvSpPr>
-        <p:spPr>
-          <a:xfrm>
-            <a:off x="594360" y="637125"/>
-            <a:ext cx="3802276" cy="5256371"/>
-          </a:xfrm>
-        </p:spPr>
-        <p:txBody>
-          <a:bodyPr>
-            <a:normAutofit/>
-          </a:bodyPr>
-          <a:lstStyle/>
-          <a:p>
-            <a:pPr algn="ctr"/>
-            <a:r>
-              <a:rPr lang="en-US" sz="8000" dirty="0">
-                <a:solidFill>
-                  <a:schemeClr val="bg1"/>
-                </a:solidFill>
-                <a:latin typeface="Algerian" panose="04020705040A02060702" pitchFamily="82" charset="0"/>
-              </a:rPr>
-              <a:t>Note </a:t>
-            </a:r>
-            <a:r>
-              <a:rPr lang="en-US" sz="8000" dirty="0">
-                <a:solidFill>
-                  <a:schemeClr val="bg1"/>
-                </a:solidFill>
-                <a:latin typeface="Algerian" panose="04020705040A02060702" pitchFamily="82" charset="0"/>
-                <a:sym typeface="Wingdings" panose="05000000000000000000" pitchFamily="2" charset="2"/>
-              </a:rPr>
-              <a:t></a:t>
-            </a:r>
-            <a:endParaRPr lang="en-US" sz="4800" dirty="0">
-              <a:solidFill>
-                <a:schemeClr val="bg1"/>
-              </a:solidFill>
-              <a:latin typeface="Algerian" panose="04020705040A02060702" pitchFamily="82" charset="0"/>
-            </a:endParaRPr>
-          </a:p>
-        </p:txBody>
-      </p:sp>
-      <p:graphicFrame>
-        <p:nvGraphicFramePr>
-          <p:cNvPr id="5" name="Content Placeholder 2">
-            <a:extLst>
-              <a:ext uri="{FF2B5EF4-FFF2-40B4-BE49-F238E27FC236}">
-                <a16:creationId xmlns:a16="http://schemas.microsoft.com/office/drawing/2014/main" id="{D0EEF94E-37CA-A384-AB85-4720D6A94F86}"/>
-              </a:ext>
-            </a:extLst>
-          </p:cNvPr>
-          <p:cNvGraphicFramePr>
-            <a:graphicFrameLocks noGrp="1"/>
-          </p:cNvGraphicFramePr>
-          <p:nvPr>
-            <p:ph idx="1"/>
-            <p:extLst>
-              <p:ext uri="{D42A27DB-BD31-4B8C-83A1-F6EECF244321}">
-                <p14:modId xmlns:p14="http://schemas.microsoft.com/office/powerpoint/2010/main" val="1711259026"/>
-              </p:ext>
-            </p:extLst>
-          </p:nvPr>
-        </p:nvGraphicFramePr>
-        <p:xfrm>
-          <a:off x="5166985" y="303591"/>
-          <a:ext cx="6588691" cy="5896743"/>
-        </p:xfrm>
-        <a:graphic>
-          <a:graphicData uri="http://schemas.openxmlformats.org/drawingml/2006/diagram">
-            <dgm:relIds xmlns:dgm="http://schemas.openxmlformats.org/drawingml/2006/diagram" xmlns:r="http://schemas.openxmlformats.org/officeDocument/2006/relationships" r:dm="rId2" r:lo="rId3" r:qs="rId4" r:cs="rId5"/>
-          </a:graphicData>
-        </a:graphic>
-      </p:graphicFrame>
-    </p:spTree>
-    <p:extLst>
-      <p:ext uri="{BB962C8B-B14F-4D97-AF65-F5344CB8AC3E}">
-        <p14:creationId xmlns:p14="http://schemas.microsoft.com/office/powerpoint/2010/main" val="314255409"/>
-      </p:ext>
-    </p:extLst>
-  </p:cSld>
-  <p:clrMapOvr>
-    <a:masterClrMapping/>
-  </p:clrMapOvr>
-</p:sld>
-</file>
-
 <file path=ppt/theme/theme1.xml><?xml version="1.0" encoding="utf-8"?>
 <a:theme xmlns:a="http://schemas.openxmlformats.org/drawingml/2006/main" name="Office Theme">
   <a:themeElements>
@@ -9535,6 +9673,21 @@
 </file>
 
 <file path=customXml/item1.xml><?xml version="1.0" encoding="utf-8"?>
+<?mso-contentType ?>
+<FormTemplates xmlns="http://schemas.microsoft.com/sharepoint/v3/contenttype/forms">
+  <Display>DocumentLibraryForm</Display>
+  <Edit>DocumentLibraryForm</Edit>
+  <New>DocumentLibraryForm</New>
+</FormTemplates>
+</file>
+
+<file path=customXml/item2.xml><?xml version="1.0" encoding="utf-8"?>
+<p:properties xmlns:p="http://schemas.microsoft.com/office/2006/metadata/properties" xmlns:xsi="http://www.w3.org/2001/XMLSchema-instance" xmlns:pc="http://schemas.microsoft.com/office/infopath/2007/PartnerControls">
+  <documentManagement/>
+</p:properties>
+</file>
+
+<file path=customXml/item3.xml><?xml version="1.0" encoding="utf-8"?>
 <ct:contentTypeSchema xmlns:ct="http://schemas.microsoft.com/office/2006/metadata/contentType" xmlns:ma="http://schemas.microsoft.com/office/2006/metadata/properties/metaAttributes" ct:_="" ma:_="" ma:contentTypeName="Document" ma:contentTypeID="0x0101006155D282FBADC0438018B9E4A20F1794" ma:contentTypeVersion="10" ma:contentTypeDescription="Create a new document." ma:contentTypeScope="" ma:versionID="b8231125008c47c1faaa61af8993e190">
   <xsd:schema xmlns:xsd="http://www.w3.org/2001/XMLSchema" xmlns:xs="http://www.w3.org/2001/XMLSchema" xmlns:p="http://schemas.microsoft.com/office/2006/metadata/properties" xmlns:ns3="e1428c55-5cd7-46bd-9849-eef71307cfa8" targetNamespace="http://schemas.microsoft.com/office/2006/metadata/properties" ma:root="true" ma:fieldsID="c45ce93ab0f0d9348c4a414f6535c4fd" ns3:_="">
     <xsd:import namespace="e1428c55-5cd7-46bd-9849-eef71307cfa8"/>
@@ -9718,35 +9871,10 @@
 </ct:contentTypeSchema>
 </file>
 
-<file path=customXml/item2.xml><?xml version="1.0" encoding="utf-8"?>
-<p:properties xmlns:p="http://schemas.microsoft.com/office/2006/metadata/properties" xmlns:xsi="http://www.w3.org/2001/XMLSchema-instance" xmlns:pc="http://schemas.microsoft.com/office/infopath/2007/PartnerControls">
-  <documentManagement/>
-</p:properties>
-</file>
-
-<file path=customXml/item3.xml><?xml version="1.0" encoding="utf-8"?>
-<?mso-contentType ?>
-<FormTemplates xmlns="http://schemas.microsoft.com/sharepoint/v3/contenttype/forms">
-  <Display>DocumentLibraryForm</Display>
-  <Edit>DocumentLibraryForm</Edit>
-  <New>DocumentLibraryForm</New>
-</FormTemplates>
-</file>
-
 <file path=customXml/itemProps1.xml><?xml version="1.0" encoding="utf-8"?>
-<ds:datastoreItem xmlns:ds="http://schemas.openxmlformats.org/officeDocument/2006/customXml" ds:itemID="{D90CDA43-2A7A-4FF9-81DE-512D0F137E74}">
+<ds:datastoreItem xmlns:ds="http://schemas.openxmlformats.org/officeDocument/2006/customXml" ds:itemID="{DF2FF713-96F6-46AA-8A68-2121576B3A3C}">
   <ds:schemaRefs>
-    <ds:schemaRef ds:uri="http://schemas.microsoft.com/office/2006/metadata/contentType"/>
-    <ds:schemaRef ds:uri="http://schemas.microsoft.com/office/2006/metadata/properties/metaAttributes"/>
-    <ds:schemaRef ds:uri="http://www.w3.org/2001/XMLSchema"/>
-    <ds:schemaRef ds:uri="http://schemas.microsoft.com/office/2006/metadata/properties"/>
-    <ds:schemaRef ds:uri="e1428c55-5cd7-46bd-9849-eef71307cfa8"/>
-    <ds:schemaRef ds:uri="http://schemas.microsoft.com/office/2006/documentManagement/types"/>
-    <ds:schemaRef ds:uri="http://schemas.microsoft.com/office/infopath/2007/PartnerControls"/>
-    <ds:schemaRef ds:uri="http://schemas.openxmlformats.org/package/2006/metadata/core-properties"/>
-    <ds:schemaRef ds:uri="http://purl.org/dc/elements/1.1/"/>
-    <ds:schemaRef ds:uri="http://purl.org/dc/terms/"/>
-    <ds:schemaRef ds:uri="http://schemas.microsoft.com/internal/obd"/>
+    <ds:schemaRef ds:uri="http://schemas.microsoft.com/sharepoint/v3/contenttype/forms"/>
   </ds:schemaRefs>
 </ds:datastoreItem>
 </file>
@@ -9768,9 +9896,19 @@
 </file>
 
 <file path=customXml/itemProps3.xml><?xml version="1.0" encoding="utf-8"?>
-<ds:datastoreItem xmlns:ds="http://schemas.openxmlformats.org/officeDocument/2006/customXml" ds:itemID="{DF2FF713-96F6-46AA-8A68-2121576B3A3C}">
+<ds:datastoreItem xmlns:ds="http://schemas.openxmlformats.org/officeDocument/2006/customXml" ds:itemID="{D90CDA43-2A7A-4FF9-81DE-512D0F137E74}">
   <ds:schemaRefs>
-    <ds:schemaRef ds:uri="http://schemas.microsoft.com/sharepoint/v3/contenttype/forms"/>
+    <ds:schemaRef ds:uri="http://schemas.microsoft.com/office/2006/metadata/contentType"/>
+    <ds:schemaRef ds:uri="http://schemas.microsoft.com/office/2006/metadata/properties/metaAttributes"/>
+    <ds:schemaRef ds:uri="http://www.w3.org/2001/XMLSchema"/>
+    <ds:schemaRef ds:uri="http://schemas.microsoft.com/office/2006/metadata/properties"/>
+    <ds:schemaRef ds:uri="e1428c55-5cd7-46bd-9849-eef71307cfa8"/>
+    <ds:schemaRef ds:uri="http://schemas.microsoft.com/office/2006/documentManagement/types"/>
+    <ds:schemaRef ds:uri="http://schemas.microsoft.com/office/infopath/2007/PartnerControls"/>
+    <ds:schemaRef ds:uri="http://schemas.openxmlformats.org/package/2006/metadata/core-properties"/>
+    <ds:schemaRef ds:uri="http://purl.org/dc/elements/1.1/"/>
+    <ds:schemaRef ds:uri="http://purl.org/dc/terms/"/>
+    <ds:schemaRef ds:uri="http://schemas.microsoft.com/internal/obd"/>
   </ds:schemaRefs>
 </ds:datastoreItem>
 </file>
</xml_diff>